<commit_message>
feat: add slide 05
</commit_message>
<xml_diff>
--- a/slide/pratica/05/05.estrutura_sequencial.pptx
+++ b/slide/pratica/05/05.estrutura_sequencial.pptx
@@ -5,32 +5,28 @@
     <p:sldMasterId id="2147483648" r:id="rId4"/>
   </p:sldMasterIdLst>
   <p:notesMasterIdLst>
-    <p:notesMasterId r:id="rId25"/>
+    <p:notesMasterId r:id="rId21"/>
   </p:notesMasterIdLst>
   <p:handoutMasterIdLst>
-    <p:handoutMasterId r:id="rId26"/>
+    <p:handoutMasterId r:id="rId22"/>
   </p:handoutMasterIdLst>
   <p:sldIdLst>
     <p:sldId id="256" r:id="rId5"/>
     <p:sldId id="278" r:id="rId6"/>
     <p:sldId id="340" r:id="rId7"/>
     <p:sldId id="341" r:id="rId8"/>
-    <p:sldId id="306" r:id="rId9"/>
-    <p:sldId id="305" r:id="rId10"/>
-    <p:sldId id="329" r:id="rId11"/>
-    <p:sldId id="330" r:id="rId12"/>
-    <p:sldId id="326" r:id="rId13"/>
-    <p:sldId id="307" r:id="rId14"/>
-    <p:sldId id="333" r:id="rId15"/>
-    <p:sldId id="342" r:id="rId16"/>
-    <p:sldId id="334" r:id="rId17"/>
-    <p:sldId id="335" r:id="rId18"/>
-    <p:sldId id="336" r:id="rId19"/>
-    <p:sldId id="337" r:id="rId20"/>
-    <p:sldId id="338" r:id="rId21"/>
-    <p:sldId id="339" r:id="rId22"/>
-    <p:sldId id="348" r:id="rId23"/>
-    <p:sldId id="349" r:id="rId24"/>
+    <p:sldId id="326" r:id="rId9"/>
+    <p:sldId id="307" r:id="rId10"/>
+    <p:sldId id="333" r:id="rId11"/>
+    <p:sldId id="342" r:id="rId12"/>
+    <p:sldId id="334" r:id="rId13"/>
+    <p:sldId id="335" r:id="rId14"/>
+    <p:sldId id="336" r:id="rId15"/>
+    <p:sldId id="337" r:id="rId16"/>
+    <p:sldId id="338" r:id="rId17"/>
+    <p:sldId id="339" r:id="rId18"/>
+    <p:sldId id="348" r:id="rId19"/>
+    <p:sldId id="349" r:id="rId20"/>
   </p:sldIdLst>
   <p:sldSz cx="12192000" cy="6858000"/>
   <p:notesSz cx="6858000" cy="9144000"/>
@@ -224,7 +220,7 @@
             <a:pPr rtl="0"/>
             <a:fld id="{07777D35-62E0-4ADA-A544-0FF8CE93EFA3}" type="datetime1">
               <a:rPr lang="pt-BR" noProof="1" smtClean="0"/>
-              <a:t>30/08/2026</a:t>
+              <a:t>03/09/2026</a:t>
             </a:fld>
             <a:endParaRPr lang="pt-BR" noProof="1"/>
           </a:p>
@@ -394,7 +390,7 @@
             <a:pPr rtl="0"/>
             <a:fld id="{90F727BD-530A-46F6-89AA-0169182CFF12}" type="datetime1">
               <a:rPr lang="pt-BR" noProof="1" smtClean="0"/>
-              <a:t>30/08/2026</a:t>
+              <a:t>03/09/2026</a:t>
             </a:fld>
             <a:endParaRPr lang="pt-BR" noProof="1"/>
           </a:p>
@@ -9545,7 +9541,7 @@
             <a:pPr rtl="0"/>
             <a:fld id="{58BA592B-0EA4-40D4-A1E4-71971A215A20}" type="datetime1">
               <a:rPr lang="pt-BR" noProof="1" smtClean="0"/>
-              <a:t>30/08/2026</a:t>
+              <a:t>03/09/2026</a:t>
             </a:fld>
             <a:endParaRPr lang="pt-BR" noProof="1"/>
           </a:p>
@@ -9749,7 +9745,7 @@
             <a:pPr rtl="0"/>
             <a:fld id="{E5D014EE-1076-4685-AE78-7B1C143CD568}" type="datetime1">
               <a:rPr lang="pt-BR" noProof="1" smtClean="0"/>
-              <a:t>30/08/2026</a:t>
+              <a:t>03/09/2026</a:t>
             </a:fld>
             <a:endParaRPr lang="pt-BR" noProof="1"/>
           </a:p>
@@ -9926,7 +9922,7 @@
             <a:pPr rtl="0"/>
             <a:fld id="{17238825-B43B-4B14-B624-1C85BDF721B5}" type="datetime1">
               <a:rPr lang="pt-BR" noProof="1" smtClean="0"/>
-              <a:t>30/08/2026</a:t>
+              <a:t>03/09/2026</a:t>
             </a:fld>
             <a:endParaRPr lang="pt-BR" noProof="1"/>
           </a:p>
@@ -10128,7 +10124,7 @@
             <a:pPr rtl="0"/>
             <a:fld id="{D1AEA189-6A12-46BC-8D40-4AE493F46DA7}" type="datetime1">
               <a:rPr lang="pt-BR" noProof="1" smtClean="0"/>
-              <a:t>30/08/2026</a:t>
+              <a:t>03/09/2026</a:t>
             </a:fld>
             <a:endParaRPr lang="pt-BR" noProof="1"/>
           </a:p>
@@ -19024,7 +19020,7 @@
             <a:pPr rtl="0"/>
             <a:fld id="{849CDA04-3929-4D47-933D-1E3D28969575}" type="datetime1">
               <a:rPr lang="pt-BR" noProof="1" smtClean="0"/>
-              <a:t>30/08/2026</a:t>
+              <a:t>03/09/2026</a:t>
             </a:fld>
             <a:endParaRPr lang="pt-BR" noProof="1"/>
           </a:p>
@@ -19294,7 +19290,7 @@
             <a:pPr rtl="0"/>
             <a:fld id="{677F04DB-A7C8-4A03-A390-FF466E07A079}" type="datetime1">
               <a:rPr lang="pt-BR" noProof="1" smtClean="0"/>
-              <a:t>30/08/2026</a:t>
+              <a:t>03/09/2026</a:t>
             </a:fld>
             <a:endParaRPr lang="pt-BR" noProof="1"/>
           </a:p>
@@ -19688,7 +19684,7 @@
             <a:pPr rtl="0"/>
             <a:fld id="{E4B593EC-2F08-44C6-ABE6-DDD998346E60}" type="datetime1">
               <a:rPr lang="pt-BR" noProof="1" smtClean="0"/>
-              <a:t>30/08/2026</a:t>
+              <a:t>03/09/2026</a:t>
             </a:fld>
             <a:endParaRPr lang="pt-BR" noProof="1"/>
           </a:p>
@@ -19804,7 +19800,7 @@
             <a:pPr rtl="0"/>
             <a:fld id="{D25D5DED-087C-4044-A01E-71A37BA13494}" type="datetime1">
               <a:rPr lang="pt-BR" noProof="1" smtClean="0"/>
-              <a:t>30/08/2026</a:t>
+              <a:t>03/09/2026</a:t>
             </a:fld>
             <a:endParaRPr lang="pt-BR" noProof="1"/>
           </a:p>
@@ -19897,7 +19893,7 @@
             <a:pPr rtl="0"/>
             <a:fld id="{808423E9-1DB6-4230-88B5-F7BE0B79B8DA}" type="datetime1">
               <a:rPr lang="pt-BR" noProof="1" smtClean="0"/>
-              <a:t>30/08/2026</a:t>
+              <a:t>03/09/2026</a:t>
             </a:fld>
             <a:endParaRPr lang="pt-BR" noProof="1"/>
           </a:p>
@@ -20184,7 +20180,7 @@
             <a:pPr rtl="0"/>
             <a:fld id="{68E18BF6-C54B-4774-B74E-64B13634CEBD}" type="datetime1">
               <a:rPr lang="pt-BR" noProof="1" smtClean="0"/>
-              <a:t>30/08/2026</a:t>
+              <a:t>03/09/2026</a:t>
             </a:fld>
             <a:endParaRPr lang="pt-BR" noProof="1"/>
           </a:p>
@@ -20462,7 +20458,7 @@
             <a:pPr rtl="0"/>
             <a:fld id="{5366459E-9F7E-4AD8-ABE1-A057363D4744}" type="datetime1">
               <a:rPr lang="pt-BR" noProof="1" smtClean="0"/>
-              <a:t>30/08/2026</a:t>
+              <a:t>03/09/2026</a:t>
             </a:fld>
             <a:endParaRPr lang="pt-BR" noProof="1"/>
           </a:p>
@@ -20709,7 +20705,7 @@
             <a:pPr rtl="0"/>
             <a:fld id="{8071EC9B-CAF5-4D8C-962A-CE3A64DB1FC2}" type="datetime1">
               <a:rPr lang="pt-BR" noProof="1" smtClean="0"/>
-              <a:t>30/08/2026</a:t>
+              <a:t>03/09/2026</a:t>
             </a:fld>
             <a:endParaRPr lang="pt-BR" noProof="1"/>
           </a:p>
@@ -21440,7 +21436,7 @@
         </p:spPr>
         <p:txBody>
           <a:bodyPr rtlCol="0" anchor="t">
-            <a:normAutofit/>
+            <a:normAutofit lnSpcReduction="10000"/>
           </a:bodyPr>
           <a:lstStyle/>
           <a:p>
@@ -21452,6 +21448,17 @@
                 </a:solidFill>
               </a:rPr>
               <a:t>Matematica Computacional Aplicada</a:t>
+            </a:r>
+          </a:p>
+          <a:p>
+            <a:pPr rtl="0"/>
+            <a:r>
+              <a:rPr lang="pt-BR" noProof="1">
+                <a:solidFill>
+                  <a:srgbClr val="FFFFFF"/>
+                </a:solidFill>
+              </a:rPr>
+              <a:t>Lógica e Algoritmos</a:t>
             </a:r>
             <a:br>
               <a:rPr lang="pt-BR" noProof="1">
@@ -21576,406 +21583,6 @@
         <p:cNvPr id="1" name="">
           <a:extLst>
             <a:ext uri="{FF2B5EF4-FFF2-40B4-BE49-F238E27FC236}">
-              <a16:creationId xmlns:a16="http://schemas.microsoft.com/office/drawing/2014/main" id="{27C4645D-27DF-19C9-6BE3-5B11D1588596}"/>
-            </a:ext>
-          </a:extLst>
-        </p:cNvPr>
-        <p:cNvGrpSpPr/>
-        <p:nvPr/>
-      </p:nvGrpSpPr>
-      <p:grpSpPr>
-        <a:xfrm>
-          <a:off x="0" y="0"/>
-          <a:ext cx="0" cy="0"/>
-          <a:chOff x="0" y="0"/>
-          <a:chExt cx="0" cy="0"/>
-        </a:xfrm>
-      </p:grpSpPr>
-      <p:sp>
-        <p:nvSpPr>
-          <p:cNvPr id="2" name="Título 1">
-            <a:extLst>
-              <a:ext uri="{FF2B5EF4-FFF2-40B4-BE49-F238E27FC236}">
-                <a16:creationId xmlns:a16="http://schemas.microsoft.com/office/drawing/2014/main" id="{5C80BD4D-98BD-97B6-ABAE-960EDAD29F87}"/>
-              </a:ext>
-            </a:extLst>
-          </p:cNvPr>
-          <p:cNvSpPr>
-            <a:spLocks noGrp="1"/>
-          </p:cNvSpPr>
-          <p:nvPr>
-            <p:ph type="title"/>
-          </p:nvPr>
-        </p:nvSpPr>
-        <p:spPr/>
-        <p:txBody>
-          <a:bodyPr/>
-          <a:lstStyle/>
-          <a:p>
-            <a:r>
-              <a:rPr lang="pt-BR" dirty="0"/>
-              <a:t>Conceito</a:t>
-            </a:r>
-          </a:p>
-        </p:txBody>
-      </p:sp>
-      <p:sp>
-        <p:nvSpPr>
-          <p:cNvPr id="3" name="Espaço Reservado para Conteúdo 2">
-            <a:extLst>
-              <a:ext uri="{FF2B5EF4-FFF2-40B4-BE49-F238E27FC236}">
-                <a16:creationId xmlns:a16="http://schemas.microsoft.com/office/drawing/2014/main" id="{3B266C91-195E-4A06-908B-3823A64C5F7E}"/>
-              </a:ext>
-            </a:extLst>
-          </p:cNvPr>
-          <p:cNvSpPr>
-            <a:spLocks noGrp="1"/>
-          </p:cNvSpPr>
-          <p:nvPr>
-            <p:ph idx="1"/>
-          </p:nvPr>
-        </p:nvSpPr>
-        <p:spPr/>
-        <p:txBody>
-          <a:bodyPr>
-            <a:noAutofit/>
-          </a:bodyPr>
-          <a:lstStyle/>
-          <a:p>
-            <a:pPr marL="0" indent="0">
-              <a:buNone/>
-            </a:pPr>
-            <a:r>
-              <a:rPr lang="pt-BR" sz="4500" dirty="0"/>
-              <a:t>Usados na realização de </a:t>
-            </a:r>
-            <a:r>
-              <a:rPr lang="pt-BR" sz="4500" b="1" dirty="0">
-                <a:solidFill>
-                  <a:srgbClr val="7030A0"/>
-                </a:solidFill>
-              </a:rPr>
-              <a:t>cálculos aritméticos simples</a:t>
-            </a:r>
-            <a:r>
-              <a:rPr lang="pt-BR" sz="4500" dirty="0"/>
-              <a:t>, usando as quatro operações básicas da matemática mais operações como o módulo.</a:t>
-            </a:r>
-          </a:p>
-        </p:txBody>
-      </p:sp>
-    </p:spTree>
-    <p:extLst>
-      <p:ext uri="{BB962C8B-B14F-4D97-AF65-F5344CB8AC3E}">
-        <p14:creationId xmlns:p14="http://schemas.microsoft.com/office/powerpoint/2010/main" val="727140148"/>
-      </p:ext>
-    </p:extLst>
-  </p:cSld>
-  <p:clrMapOvr>
-    <a:masterClrMapping/>
-  </p:clrMapOvr>
-</p:sld>
-</file>
-
-<file path=ppt/slides/slide11.xml><?xml version="1.0" encoding="utf-8"?>
-<p:sld xmlns:a="http://schemas.openxmlformats.org/drawingml/2006/main" xmlns:r="http://schemas.openxmlformats.org/officeDocument/2006/relationships" xmlns:p="http://schemas.openxmlformats.org/presentationml/2006/main">
-  <p:cSld>
-    <p:spTree>
-      <p:nvGrpSpPr>
-        <p:cNvPr id="1" name="">
-          <a:extLst>
-            <a:ext uri="{FF2B5EF4-FFF2-40B4-BE49-F238E27FC236}">
-              <a16:creationId xmlns:a16="http://schemas.microsoft.com/office/drawing/2014/main" id="{DC97B1F4-E431-F466-D2C4-901ADB8E143A}"/>
-            </a:ext>
-          </a:extLst>
-        </p:cNvPr>
-        <p:cNvGrpSpPr/>
-        <p:nvPr/>
-      </p:nvGrpSpPr>
-      <p:grpSpPr>
-        <a:xfrm>
-          <a:off x="0" y="0"/>
-          <a:ext cx="0" cy="0"/>
-          <a:chOff x="0" y="0"/>
-          <a:chExt cx="0" cy="0"/>
-        </a:xfrm>
-      </p:grpSpPr>
-      <p:pic>
-        <p:nvPicPr>
-          <p:cNvPr id="9" name="Imagem 8">
-            <a:extLst>
-              <a:ext uri="{FF2B5EF4-FFF2-40B4-BE49-F238E27FC236}">
-                <a16:creationId xmlns:a16="http://schemas.microsoft.com/office/drawing/2014/main" id="{623DDFBA-EF55-3E40-17EF-42E49E6A4A8B}"/>
-              </a:ext>
-            </a:extLst>
-          </p:cNvPr>
-          <p:cNvPicPr>
-            <a:picLocks noChangeAspect="1"/>
-          </p:cNvPicPr>
-          <p:nvPr/>
-        </p:nvPicPr>
-        <p:blipFill>
-          <a:blip r:embed="rId2"/>
-          <a:stretch>
-            <a:fillRect/>
-          </a:stretch>
-        </p:blipFill>
-        <p:spPr>
-          <a:xfrm>
-            <a:off x="257400" y="0"/>
-            <a:ext cx="11677200" cy="6858000"/>
-          </a:xfrm>
-          <a:prstGeom prst="rect">
-            <a:avLst/>
-          </a:prstGeom>
-        </p:spPr>
-      </p:pic>
-    </p:spTree>
-    <p:extLst>
-      <p:ext uri="{BB962C8B-B14F-4D97-AF65-F5344CB8AC3E}">
-        <p14:creationId xmlns:p14="http://schemas.microsoft.com/office/powerpoint/2010/main" val="1350771419"/>
-      </p:ext>
-    </p:extLst>
-  </p:cSld>
-  <p:clrMapOvr>
-    <a:masterClrMapping/>
-  </p:clrMapOvr>
-</p:sld>
-</file>
-
-<file path=ppt/slides/slide12.xml><?xml version="1.0" encoding="utf-8"?>
-<p:sld xmlns:a="http://schemas.openxmlformats.org/drawingml/2006/main" xmlns:r="http://schemas.openxmlformats.org/officeDocument/2006/relationships" xmlns:p="http://schemas.openxmlformats.org/presentationml/2006/main">
-  <p:cSld>
-    <p:spTree>
-      <p:nvGrpSpPr>
-        <p:cNvPr id="1" name="">
-          <a:extLst>
-            <a:ext uri="{FF2B5EF4-FFF2-40B4-BE49-F238E27FC236}">
-              <a16:creationId xmlns:a16="http://schemas.microsoft.com/office/drawing/2014/main" id="{137D7C11-0628-FF0E-4B48-5278DC8D8BEA}"/>
-            </a:ext>
-          </a:extLst>
-        </p:cNvPr>
-        <p:cNvGrpSpPr/>
-        <p:nvPr/>
-      </p:nvGrpSpPr>
-      <p:grpSpPr>
-        <a:xfrm>
-          <a:off x="0" y="0"/>
-          <a:ext cx="0" cy="0"/>
-          <a:chOff x="0" y="0"/>
-          <a:chExt cx="0" cy="0"/>
-        </a:xfrm>
-      </p:grpSpPr>
-      <p:pic>
-        <p:nvPicPr>
-          <p:cNvPr id="9" name="Imagem 8">
-            <a:extLst>
-              <a:ext uri="{FF2B5EF4-FFF2-40B4-BE49-F238E27FC236}">
-                <a16:creationId xmlns:a16="http://schemas.microsoft.com/office/drawing/2014/main" id="{AFD7632F-FB1A-7A2B-9265-C5AA246CB316}"/>
-              </a:ext>
-            </a:extLst>
-          </p:cNvPr>
-          <p:cNvPicPr>
-            <a:picLocks noChangeAspect="1"/>
-          </p:cNvPicPr>
-          <p:nvPr/>
-        </p:nvPicPr>
-        <p:blipFill>
-          <a:blip r:embed="rId2"/>
-          <a:srcRect/>
-          <a:stretch/>
-        </p:blipFill>
-        <p:spPr>
-          <a:xfrm>
-            <a:off x="257400" y="430083"/>
-            <a:ext cx="11677200" cy="5997834"/>
-          </a:xfrm>
-          <a:prstGeom prst="rect">
-            <a:avLst/>
-          </a:prstGeom>
-        </p:spPr>
-      </p:pic>
-    </p:spTree>
-    <p:extLst>
-      <p:ext uri="{BB962C8B-B14F-4D97-AF65-F5344CB8AC3E}">
-        <p14:creationId xmlns:p14="http://schemas.microsoft.com/office/powerpoint/2010/main" val="741721956"/>
-      </p:ext>
-    </p:extLst>
-  </p:cSld>
-  <p:clrMapOvr>
-    <a:masterClrMapping/>
-  </p:clrMapOvr>
-</p:sld>
-</file>
-
-<file path=ppt/slides/slide13.xml><?xml version="1.0" encoding="utf-8"?>
-<p:sld xmlns:a="http://schemas.openxmlformats.org/drawingml/2006/main" xmlns:r="http://schemas.openxmlformats.org/officeDocument/2006/relationships" xmlns:p="http://schemas.openxmlformats.org/presentationml/2006/main">
-  <p:cSld>
-    <p:spTree>
-      <p:nvGrpSpPr>
-        <p:cNvPr id="1" name="">
-          <a:extLst>
-            <a:ext uri="{FF2B5EF4-FFF2-40B4-BE49-F238E27FC236}">
-              <a16:creationId xmlns:a16="http://schemas.microsoft.com/office/drawing/2014/main" id="{0EE355CC-8725-F014-E969-74E1C4F052DD}"/>
-            </a:ext>
-          </a:extLst>
-        </p:cNvPr>
-        <p:cNvGrpSpPr/>
-        <p:nvPr/>
-      </p:nvGrpSpPr>
-      <p:grpSpPr>
-        <a:xfrm>
-          <a:off x="0" y="0"/>
-          <a:ext cx="0" cy="0"/>
-          <a:chOff x="0" y="0"/>
-          <a:chExt cx="0" cy="0"/>
-        </a:xfrm>
-      </p:grpSpPr>
-      <p:sp>
-        <p:nvSpPr>
-          <p:cNvPr id="3" name="Espaço Reservado para Conteúdo 2">
-            <a:extLst>
-              <a:ext uri="{FF2B5EF4-FFF2-40B4-BE49-F238E27FC236}">
-                <a16:creationId xmlns:a16="http://schemas.microsoft.com/office/drawing/2014/main" id="{E5737209-E3FE-700D-1279-75E13CF0CB78}"/>
-              </a:ext>
-            </a:extLst>
-          </p:cNvPr>
-          <p:cNvSpPr>
-            <a:spLocks noGrp="1"/>
-          </p:cNvSpPr>
-          <p:nvPr>
-            <p:ph idx="1"/>
-          </p:nvPr>
-        </p:nvSpPr>
-        <p:spPr>
-          <a:xfrm>
-            <a:off x="1024128" y="651933"/>
-            <a:ext cx="10558272" cy="5657427"/>
-          </a:xfrm>
-        </p:spPr>
-        <p:txBody>
-          <a:bodyPr>
-            <a:noAutofit/>
-          </a:bodyPr>
-          <a:lstStyle/>
-          <a:p>
-            <a:pPr marL="0" indent="0">
-              <a:buNone/>
-            </a:pPr>
-            <a:r>
-              <a:rPr lang="pt-BR" sz="4500" dirty="0">
-                <a:latin typeface="Cascadia Code" panose="020B0609020000020004" pitchFamily="49" charset="0"/>
-                <a:cs typeface="Cascadia Code" panose="020B0609020000020004" pitchFamily="49" charset="0"/>
-              </a:rPr>
-              <a:t>		</a:t>
-            </a:r>
-            <a:r>
-              <a:rPr lang="pl-PL" sz="4500" dirty="0">
-                <a:latin typeface="Cascadia Code" panose="020B0609020000020004" pitchFamily="49" charset="0"/>
-                <a:cs typeface="Cascadia Code" panose="020B0609020000020004" pitchFamily="49" charset="0"/>
-              </a:rPr>
-              <a:t>x = 2 * 3</a:t>
-            </a:r>
-          </a:p>
-          <a:p>
-            <a:pPr marL="0" indent="0">
-              <a:buNone/>
-            </a:pPr>
-            <a:r>
-              <a:rPr lang="pl-PL" sz="4500" dirty="0">
-                <a:latin typeface="Cascadia Code" panose="020B0609020000020004" pitchFamily="49" charset="0"/>
-                <a:cs typeface="Cascadia Code" panose="020B0609020000020004" pitchFamily="49" charset="0"/>
-              </a:rPr>
-              <a:t>		y = 5 * 2 * 2</a:t>
-            </a:r>
-          </a:p>
-          <a:p>
-            <a:pPr marL="0" indent="0">
-              <a:buNone/>
-            </a:pPr>
-            <a:r>
-              <a:rPr lang="pl-PL" sz="4500" dirty="0">
-                <a:latin typeface="Cascadia Code" panose="020B0609020000020004" pitchFamily="49" charset="0"/>
-                <a:cs typeface="Cascadia Code" panose="020B0609020000020004" pitchFamily="49" charset="0"/>
-              </a:rPr>
-              <a:t>		z = 4 % 2</a:t>
-            </a:r>
-          </a:p>
-          <a:p>
-            <a:pPr marL="0" indent="0">
-              <a:buNone/>
-            </a:pPr>
-            <a:r>
-              <a:rPr lang="pl-PL" sz="4500" dirty="0">
-                <a:latin typeface="Cascadia Code" panose="020B0609020000020004" pitchFamily="49" charset="0"/>
-                <a:cs typeface="Cascadia Code" panose="020B0609020000020004" pitchFamily="49" charset="0"/>
-              </a:rPr>
-              <a:t>		w = 8 / 4</a:t>
-            </a:r>
-          </a:p>
-          <a:p>
-            <a:pPr marL="0" indent="0">
-              <a:buNone/>
-            </a:pPr>
-            <a:r>
-              <a:rPr lang="pl-PL" sz="4500" dirty="0">
-                <a:latin typeface="Cascadia Code" panose="020B0609020000020004" pitchFamily="49" charset="0"/>
-                <a:cs typeface="Cascadia Code" panose="020B0609020000020004" pitchFamily="49" charset="0"/>
-              </a:rPr>
-              <a:t>		k = 7 / 2</a:t>
-            </a:r>
-          </a:p>
-          <a:p>
-            <a:pPr marL="0" indent="0">
-              <a:buNone/>
-            </a:pPr>
-            <a:r>
-              <a:rPr lang="pl-PL" sz="4500" dirty="0">
-                <a:latin typeface="Cascadia Code" panose="020B0609020000020004" pitchFamily="49" charset="0"/>
-                <a:cs typeface="Cascadia Code" panose="020B0609020000020004" pitchFamily="49" charset="0"/>
-              </a:rPr>
-              <a:t>		m = w + x * 3</a:t>
-            </a:r>
-          </a:p>
-          <a:p>
-            <a:pPr marL="0" indent="0">
-              <a:buNone/>
-            </a:pPr>
-            <a:r>
-              <a:rPr lang="pl-PL" sz="4500" dirty="0">
-                <a:latin typeface="Cascadia Code" panose="020B0609020000020004" pitchFamily="49" charset="0"/>
-                <a:cs typeface="Cascadia Code" panose="020B0609020000020004" pitchFamily="49" charset="0"/>
-              </a:rPr>
-              <a:t>		n = (m - k) / 2.0</a:t>
-            </a:r>
-            <a:endParaRPr lang="pt-BR" sz="4500" dirty="0">
-              <a:latin typeface="Cascadia Code" panose="020B0609020000020004" pitchFamily="49" charset="0"/>
-              <a:cs typeface="Cascadia Code" panose="020B0609020000020004" pitchFamily="49" charset="0"/>
-            </a:endParaRPr>
-          </a:p>
-        </p:txBody>
-      </p:sp>
-    </p:spTree>
-    <p:extLst>
-      <p:ext uri="{BB962C8B-B14F-4D97-AF65-F5344CB8AC3E}">
-        <p14:creationId xmlns:p14="http://schemas.microsoft.com/office/powerpoint/2010/main" val="1121112338"/>
-      </p:ext>
-    </p:extLst>
-  </p:cSld>
-  <p:clrMapOvr>
-    <a:masterClrMapping/>
-  </p:clrMapOvr>
-</p:sld>
-</file>
-
-<file path=ppt/slides/slide14.xml><?xml version="1.0" encoding="utf-8"?>
-<p:sld xmlns:a="http://schemas.openxmlformats.org/drawingml/2006/main" xmlns:r="http://schemas.openxmlformats.org/officeDocument/2006/relationships" xmlns:p="http://schemas.openxmlformats.org/presentationml/2006/main">
-  <p:cSld>
-    <p:spTree>
-      <p:nvGrpSpPr>
-        <p:cNvPr id="1" name="">
-          <a:extLst>
-            <a:ext uri="{FF2B5EF4-FFF2-40B4-BE49-F238E27FC236}">
               <a16:creationId xmlns:a16="http://schemas.microsoft.com/office/drawing/2014/main" id="{B49A2741-B6DE-6D6D-40C3-5CCF58C5B280}"/>
             </a:ext>
           </a:extLst>
@@ -22033,7 +21640,7 @@
 </p:sld>
 </file>
 
-<file path=ppt/slides/slide15.xml><?xml version="1.0" encoding="utf-8"?>
+<file path=ppt/slides/slide11.xml><?xml version="1.0" encoding="utf-8"?>
 <p:sld xmlns:a="http://schemas.openxmlformats.org/drawingml/2006/main" xmlns:r="http://schemas.openxmlformats.org/officeDocument/2006/relationships" xmlns:p="http://schemas.openxmlformats.org/presentationml/2006/main">
   <p:cSld>
     <p:spTree>
@@ -22098,7 +21705,7 @@
 </p:sld>
 </file>
 
-<file path=ppt/slides/slide16.xml><?xml version="1.0" encoding="utf-8"?>
+<file path=ppt/slides/slide12.xml><?xml version="1.0" encoding="utf-8"?>
 <p:sld xmlns:a="http://schemas.openxmlformats.org/drawingml/2006/main" xmlns:r="http://schemas.openxmlformats.org/officeDocument/2006/relationships" xmlns:p="http://schemas.openxmlformats.org/presentationml/2006/main">
   <p:cSld>
     <p:spTree>
@@ -22202,7 +21809,7 @@
 </p:sld>
 </file>
 
-<file path=ppt/slides/slide17.xml><?xml version="1.0" encoding="utf-8"?>
+<file path=ppt/slides/slide13.xml><?xml version="1.0" encoding="utf-8"?>
 <p:sld xmlns:a="http://schemas.openxmlformats.org/drawingml/2006/main" xmlns:r="http://schemas.openxmlformats.org/officeDocument/2006/relationships" xmlns:p="http://schemas.openxmlformats.org/presentationml/2006/main">
   <p:cSld>
     <p:spTree>
@@ -22267,7 +21874,7 @@
 </p:sld>
 </file>
 
-<file path=ppt/slides/slide18.xml><?xml version="1.0" encoding="utf-8"?>
+<file path=ppt/slides/slide14.xml><?xml version="1.0" encoding="utf-8"?>
 <p:sld xmlns:a="http://schemas.openxmlformats.org/drawingml/2006/main" xmlns:r="http://schemas.openxmlformats.org/officeDocument/2006/relationships" xmlns:p="http://schemas.openxmlformats.org/presentationml/2006/main">
   <p:cSld>
     <p:spTree>
@@ -22332,7 +21939,7 @@
 </p:sld>
 </file>
 
-<file path=ppt/slides/slide19.xml><?xml version="1.0" encoding="utf-8"?>
+<file path=ppt/slides/slide15.xml><?xml version="1.0" encoding="utf-8"?>
 <p:sld xmlns:a="http://schemas.openxmlformats.org/drawingml/2006/main" xmlns:r="http://schemas.openxmlformats.org/officeDocument/2006/relationships" xmlns:p="http://schemas.openxmlformats.org/presentationml/2006/main">
   <p:cSld>
     <p:spTree>
@@ -22398,68 +22005,7 @@
 </p:sld>
 </file>
 
-<file path=ppt/slides/slide2.xml><?xml version="1.0" encoding="utf-8"?>
-<p:sld xmlns:a="http://schemas.openxmlformats.org/drawingml/2006/main" xmlns:r="http://schemas.openxmlformats.org/officeDocument/2006/relationships" xmlns:p="http://schemas.openxmlformats.org/presentationml/2006/main">
-  <p:cSld>
-    <p:spTree>
-      <p:nvGrpSpPr>
-        <p:cNvPr id="1" name=""/>
-        <p:cNvGrpSpPr/>
-        <p:nvPr/>
-      </p:nvGrpSpPr>
-      <p:grpSpPr>
-        <a:xfrm>
-          <a:off x="0" y="0"/>
-          <a:ext cx="0" cy="0"/>
-          <a:chOff x="0" y="0"/>
-          <a:chExt cx="0" cy="0"/>
-        </a:xfrm>
-      </p:grpSpPr>
-      <p:pic>
-        <p:nvPicPr>
-          <p:cNvPr id="5" name="Espaço Reservado para Conteúdo 4">
-            <a:extLst>
-              <a:ext uri="{FF2B5EF4-FFF2-40B4-BE49-F238E27FC236}">
-                <a16:creationId xmlns:a16="http://schemas.microsoft.com/office/drawing/2014/main" id="{C518D2D6-5C60-5956-4E4A-48D7F8F7AF9A}"/>
-              </a:ext>
-            </a:extLst>
-          </p:cNvPr>
-          <p:cNvPicPr>
-            <a:picLocks noGrp="1" noChangeAspect="1"/>
-          </p:cNvPicPr>
-          <p:nvPr>
-            <p:ph idx="4294967295"/>
-          </p:nvPr>
-        </p:nvPicPr>
-        <p:blipFill>
-          <a:blip r:embed="rId2"/>
-          <a:srcRect/>
-          <a:stretch/>
-        </p:blipFill>
-        <p:spPr>
-          <a:xfrm>
-            <a:off x="2771775" y="104775"/>
-            <a:ext cx="6648450" cy="6648450"/>
-          </a:xfrm>
-          <a:effectLst>
-            <a:softEdge rad="317500"/>
-          </a:effectLst>
-        </p:spPr>
-      </p:pic>
-    </p:spTree>
-    <p:extLst>
-      <p:ext uri="{BB962C8B-B14F-4D97-AF65-F5344CB8AC3E}">
-        <p14:creationId xmlns:p14="http://schemas.microsoft.com/office/powerpoint/2010/main" val="3297785359"/>
-      </p:ext>
-    </p:extLst>
-  </p:cSld>
-  <p:clrMapOvr>
-    <a:masterClrMapping/>
-  </p:clrMapOvr>
-</p:sld>
-</file>
-
-<file path=ppt/slides/slide20.xml><?xml version="1.0" encoding="utf-8"?>
+<file path=ppt/slides/slide16.xml><?xml version="1.0" encoding="utf-8"?>
 <p:sld xmlns:a="http://schemas.openxmlformats.org/drawingml/2006/main" xmlns:r="http://schemas.openxmlformats.org/officeDocument/2006/relationships" xmlns:p="http://schemas.openxmlformats.org/presentationml/2006/main">
   <p:cSld>
     <p:spTree>
@@ -22622,6 +22168,67 @@
     <p:extLst>
       <p:ext uri="{BB962C8B-B14F-4D97-AF65-F5344CB8AC3E}">
         <p14:creationId xmlns:p14="http://schemas.microsoft.com/office/powerpoint/2010/main" val="3883764622"/>
+      </p:ext>
+    </p:extLst>
+  </p:cSld>
+  <p:clrMapOvr>
+    <a:masterClrMapping/>
+  </p:clrMapOvr>
+</p:sld>
+</file>
+
+<file path=ppt/slides/slide2.xml><?xml version="1.0" encoding="utf-8"?>
+<p:sld xmlns:a="http://schemas.openxmlformats.org/drawingml/2006/main" xmlns:r="http://schemas.openxmlformats.org/officeDocument/2006/relationships" xmlns:p="http://schemas.openxmlformats.org/presentationml/2006/main">
+  <p:cSld>
+    <p:spTree>
+      <p:nvGrpSpPr>
+        <p:cNvPr id="1" name=""/>
+        <p:cNvGrpSpPr/>
+        <p:nvPr/>
+      </p:nvGrpSpPr>
+      <p:grpSpPr>
+        <a:xfrm>
+          <a:off x="0" y="0"/>
+          <a:ext cx="0" cy="0"/>
+          <a:chOff x="0" y="0"/>
+          <a:chExt cx="0" cy="0"/>
+        </a:xfrm>
+      </p:grpSpPr>
+      <p:pic>
+        <p:nvPicPr>
+          <p:cNvPr id="5" name="Espaço Reservado para Conteúdo 4">
+            <a:extLst>
+              <a:ext uri="{FF2B5EF4-FFF2-40B4-BE49-F238E27FC236}">
+                <a16:creationId xmlns:a16="http://schemas.microsoft.com/office/drawing/2014/main" id="{C518D2D6-5C60-5956-4E4A-48D7F8F7AF9A}"/>
+              </a:ext>
+            </a:extLst>
+          </p:cNvPr>
+          <p:cNvPicPr>
+            <a:picLocks noGrp="1" noChangeAspect="1"/>
+          </p:cNvPicPr>
+          <p:nvPr>
+            <p:ph idx="4294967295"/>
+          </p:nvPr>
+        </p:nvPicPr>
+        <p:blipFill>
+          <a:blip r:embed="rId2"/>
+          <a:srcRect/>
+          <a:stretch/>
+        </p:blipFill>
+        <p:spPr>
+          <a:xfrm>
+            <a:off x="2771775" y="104775"/>
+            <a:ext cx="6648450" cy="6648450"/>
+          </a:xfrm>
+          <a:effectLst>
+            <a:softEdge rad="317500"/>
+          </a:effectLst>
+        </p:spPr>
+      </p:pic>
+    </p:spTree>
+    <p:extLst>
+      <p:ext uri="{BB962C8B-B14F-4D97-AF65-F5344CB8AC3E}">
+        <p14:creationId xmlns:p14="http://schemas.microsoft.com/office/powerpoint/2010/main" val="3297785359"/>
       </p:ext>
     </p:extLst>
   </p:cSld>
@@ -22802,380 +22409,6 @@
   <p:cSld>
     <p:spTree>
       <p:nvGrpSpPr>
-        <p:cNvPr id="1" name=""/>
-        <p:cNvGrpSpPr/>
-        <p:nvPr/>
-      </p:nvGrpSpPr>
-      <p:grpSpPr>
-        <a:xfrm>
-          <a:off x="0" y="0"/>
-          <a:ext cx="0" cy="0"/>
-          <a:chOff x="0" y="0"/>
-          <a:chExt cx="0" cy="0"/>
-        </a:xfrm>
-      </p:grpSpPr>
-      <p:sp>
-        <p:nvSpPr>
-          <p:cNvPr id="4" name="Título 3">
-            <a:extLst>
-              <a:ext uri="{FF2B5EF4-FFF2-40B4-BE49-F238E27FC236}">
-                <a16:creationId xmlns:a16="http://schemas.microsoft.com/office/drawing/2014/main" id="{7EE24FD9-F546-7787-9379-F3806E24E041}"/>
-              </a:ext>
-            </a:extLst>
-          </p:cNvPr>
-          <p:cNvSpPr>
-            <a:spLocks noGrp="1"/>
-          </p:cNvSpPr>
-          <p:nvPr>
-            <p:ph type="title"/>
-          </p:nvPr>
-        </p:nvSpPr>
-        <p:spPr/>
-        <p:txBody>
-          <a:bodyPr/>
-          <a:lstStyle/>
-          <a:p>
-            <a:r>
-              <a:rPr lang="pt-BR" dirty="0" err="1"/>
-              <a:t>Hello</a:t>
-            </a:r>
-            <a:r>
-              <a:rPr lang="pt-BR" dirty="0"/>
-              <a:t> World</a:t>
-            </a:r>
-          </a:p>
-        </p:txBody>
-      </p:sp>
-      <p:pic>
-        <p:nvPicPr>
-          <p:cNvPr id="7" name="Espaço Reservado para Imagem 6">
-            <a:extLst>
-              <a:ext uri="{FF2B5EF4-FFF2-40B4-BE49-F238E27FC236}">
-                <a16:creationId xmlns:a16="http://schemas.microsoft.com/office/drawing/2014/main" id="{8DA1AA89-BED5-4DC8-8148-6C81A57751C4}"/>
-              </a:ext>
-            </a:extLst>
-          </p:cNvPr>
-          <p:cNvPicPr>
-            <a:picLocks noGrp="1" noChangeAspect="1"/>
-          </p:cNvPicPr>
-          <p:nvPr>
-            <p:ph type="pic" idx="1"/>
-          </p:nvPr>
-        </p:nvPicPr>
-        <p:blipFill>
-          <a:blip r:embed="rId2"/>
-          <a:srcRect t="16658" b="16658"/>
-          <a:stretch>
-            <a:fillRect/>
-          </a:stretch>
-        </p:blipFill>
-        <p:spPr>
-          <a:prstGeom prst="rect">
-            <a:avLst/>
-          </a:prstGeom>
-        </p:spPr>
-      </p:pic>
-      <p:sp>
-        <p:nvSpPr>
-          <p:cNvPr id="6" name="Espaço Reservado para Texto 5">
-            <a:extLst>
-              <a:ext uri="{FF2B5EF4-FFF2-40B4-BE49-F238E27FC236}">
-                <a16:creationId xmlns:a16="http://schemas.microsoft.com/office/drawing/2014/main" id="{5D8FFF52-729A-7816-875C-BEC92D8A5222}"/>
-              </a:ext>
-            </a:extLst>
-          </p:cNvPr>
-          <p:cNvSpPr>
-            <a:spLocks noGrp="1"/>
-          </p:cNvSpPr>
-          <p:nvPr>
-            <p:ph type="body" sz="half" idx="2"/>
-          </p:nvPr>
-        </p:nvSpPr>
-        <p:spPr/>
-        <p:txBody>
-          <a:bodyPr/>
-          <a:lstStyle/>
-          <a:p>
-            <a:endParaRPr lang="pt-BR"/>
-          </a:p>
-        </p:txBody>
-      </p:sp>
-    </p:spTree>
-    <p:extLst>
-      <p:ext uri="{BB962C8B-B14F-4D97-AF65-F5344CB8AC3E}">
-        <p14:creationId xmlns:p14="http://schemas.microsoft.com/office/powerpoint/2010/main" val="2216557751"/>
-      </p:ext>
-    </p:extLst>
-  </p:cSld>
-  <p:clrMapOvr>
-    <a:masterClrMapping/>
-  </p:clrMapOvr>
-</p:sld>
-</file>
-
-<file path=ppt/slides/slide6.xml><?xml version="1.0" encoding="utf-8"?>
-<p:sld xmlns:a="http://schemas.openxmlformats.org/drawingml/2006/main" xmlns:r="http://schemas.openxmlformats.org/officeDocument/2006/relationships" xmlns:p="http://schemas.openxmlformats.org/presentationml/2006/main">
-  <p:cSld>
-    <p:spTree>
-      <p:nvGrpSpPr>
-        <p:cNvPr id="1" name="">
-          <a:extLst>
-            <a:ext uri="{FF2B5EF4-FFF2-40B4-BE49-F238E27FC236}">
-              <a16:creationId xmlns:a16="http://schemas.microsoft.com/office/drawing/2014/main" id="{B3EF8FC2-FA63-F7EA-AD1D-859BAE52597F}"/>
-            </a:ext>
-          </a:extLst>
-        </p:cNvPr>
-        <p:cNvGrpSpPr/>
-        <p:nvPr/>
-      </p:nvGrpSpPr>
-      <p:grpSpPr>
-        <a:xfrm>
-          <a:off x="0" y="0"/>
-          <a:ext cx="0" cy="0"/>
-          <a:chOff x="0" y="0"/>
-          <a:chExt cx="0" cy="0"/>
-        </a:xfrm>
-      </p:grpSpPr>
-      <p:sp>
-        <p:nvSpPr>
-          <p:cNvPr id="2" name="Título 1">
-            <a:extLst>
-              <a:ext uri="{FF2B5EF4-FFF2-40B4-BE49-F238E27FC236}">
-                <a16:creationId xmlns:a16="http://schemas.microsoft.com/office/drawing/2014/main" id="{7ECF6023-E0AA-74A1-3134-21C177675F98}"/>
-              </a:ext>
-            </a:extLst>
-          </p:cNvPr>
-          <p:cNvSpPr>
-            <a:spLocks noGrp="1"/>
-          </p:cNvSpPr>
-          <p:nvPr>
-            <p:ph type="title"/>
-          </p:nvPr>
-        </p:nvSpPr>
-        <p:spPr/>
-        <p:txBody>
-          <a:bodyPr/>
-          <a:lstStyle/>
-          <a:p>
-            <a:r>
-              <a:rPr lang="pt-BR" dirty="0" err="1"/>
-              <a:t>Portugol</a:t>
-            </a:r>
-            <a:endParaRPr lang="pt-BR" dirty="0"/>
-          </a:p>
-        </p:txBody>
-      </p:sp>
-      <p:sp>
-        <p:nvSpPr>
-          <p:cNvPr id="3" name="Espaço Reservado para Conteúdo 2">
-            <a:extLst>
-              <a:ext uri="{FF2B5EF4-FFF2-40B4-BE49-F238E27FC236}">
-                <a16:creationId xmlns:a16="http://schemas.microsoft.com/office/drawing/2014/main" id="{D095BC37-EC7D-E9D1-F65A-9CB9347B3AB6}"/>
-              </a:ext>
-            </a:extLst>
-          </p:cNvPr>
-          <p:cNvSpPr>
-            <a:spLocks noGrp="1"/>
-          </p:cNvSpPr>
-          <p:nvPr>
-            <p:ph idx="1"/>
-          </p:nvPr>
-        </p:nvSpPr>
-        <p:spPr/>
-        <p:txBody>
-          <a:bodyPr>
-            <a:noAutofit/>
-          </a:bodyPr>
-          <a:lstStyle/>
-          <a:p>
-            <a:pPr marL="0" indent="0">
-              <a:buNone/>
-            </a:pPr>
-            <a:r>
-              <a:rPr lang="pt-BR" sz="4500" dirty="0"/>
-              <a:t>Vamos fazer um programa simples no </a:t>
-            </a:r>
-            <a:r>
-              <a:rPr lang="pt-BR" sz="4500" dirty="0" err="1"/>
-              <a:t>Portugol</a:t>
-            </a:r>
-            <a:r>
-              <a:rPr lang="pt-BR" sz="4500" dirty="0"/>
-              <a:t>!</a:t>
-            </a:r>
-          </a:p>
-          <a:p>
-            <a:pPr marL="0" indent="0">
-              <a:buNone/>
-            </a:pPr>
-            <a:r>
-              <a:rPr lang="pt-BR" sz="4500" dirty="0"/>
-              <a:t>O famoso </a:t>
-            </a:r>
-            <a:r>
-              <a:rPr lang="pt-BR" sz="4500" i="1" dirty="0" err="1"/>
-              <a:t>Hello</a:t>
-            </a:r>
-            <a:r>
-              <a:rPr lang="pt-BR" sz="4500" i="1" dirty="0"/>
-              <a:t> World </a:t>
-            </a:r>
-            <a:r>
-              <a:rPr lang="pt-BR" sz="4500" dirty="0"/>
-              <a:t>da Programação.</a:t>
-            </a:r>
-          </a:p>
-        </p:txBody>
-      </p:sp>
-    </p:spTree>
-    <p:extLst>
-      <p:ext uri="{BB962C8B-B14F-4D97-AF65-F5344CB8AC3E}">
-        <p14:creationId xmlns:p14="http://schemas.microsoft.com/office/powerpoint/2010/main" val="4091454666"/>
-      </p:ext>
-    </p:extLst>
-  </p:cSld>
-  <p:clrMapOvr>
-    <a:masterClrMapping/>
-  </p:clrMapOvr>
-</p:sld>
-</file>
-
-<file path=ppt/slides/slide7.xml><?xml version="1.0" encoding="utf-8"?>
-<p:sld xmlns:a="http://schemas.openxmlformats.org/drawingml/2006/main" xmlns:r="http://schemas.openxmlformats.org/officeDocument/2006/relationships" xmlns:p="http://schemas.openxmlformats.org/presentationml/2006/main">
-  <p:cSld>
-    <p:spTree>
-      <p:nvGrpSpPr>
-        <p:cNvPr id="1" name="">
-          <a:extLst>
-            <a:ext uri="{FF2B5EF4-FFF2-40B4-BE49-F238E27FC236}">
-              <a16:creationId xmlns:a16="http://schemas.microsoft.com/office/drawing/2014/main" id="{6DA5868E-DBBE-7B4D-5FA0-3B5D02A16044}"/>
-            </a:ext>
-          </a:extLst>
-        </p:cNvPr>
-        <p:cNvGrpSpPr/>
-        <p:nvPr/>
-      </p:nvGrpSpPr>
-      <p:grpSpPr>
-        <a:xfrm>
-          <a:off x="0" y="0"/>
-          <a:ext cx="0" cy="0"/>
-          <a:chOff x="0" y="0"/>
-          <a:chExt cx="0" cy="0"/>
-        </a:xfrm>
-      </p:grpSpPr>
-      <p:pic>
-        <p:nvPicPr>
-          <p:cNvPr id="8" name="Imagem 7">
-            <a:extLst>
-              <a:ext uri="{FF2B5EF4-FFF2-40B4-BE49-F238E27FC236}">
-                <a16:creationId xmlns:a16="http://schemas.microsoft.com/office/drawing/2014/main" id="{337D703E-BA42-7451-F03F-F51A4013D273}"/>
-              </a:ext>
-            </a:extLst>
-          </p:cNvPr>
-          <p:cNvPicPr>
-            <a:picLocks noChangeAspect="1"/>
-          </p:cNvPicPr>
-          <p:nvPr/>
-        </p:nvPicPr>
-        <p:blipFill>
-          <a:blip r:embed="rId2"/>
-          <a:stretch>
-            <a:fillRect/>
-          </a:stretch>
-        </p:blipFill>
-        <p:spPr>
-          <a:xfrm>
-            <a:off x="139700" y="284627"/>
-            <a:ext cx="11912600" cy="6288746"/>
-          </a:xfrm>
-          <a:prstGeom prst="rect">
-            <a:avLst/>
-          </a:prstGeom>
-        </p:spPr>
-      </p:pic>
-    </p:spTree>
-    <p:extLst>
-      <p:ext uri="{BB962C8B-B14F-4D97-AF65-F5344CB8AC3E}">
-        <p14:creationId xmlns:p14="http://schemas.microsoft.com/office/powerpoint/2010/main" val="2353984122"/>
-      </p:ext>
-    </p:extLst>
-  </p:cSld>
-  <p:clrMapOvr>
-    <a:masterClrMapping/>
-  </p:clrMapOvr>
-</p:sld>
-</file>
-
-<file path=ppt/slides/slide8.xml><?xml version="1.0" encoding="utf-8"?>
-<p:sld xmlns:a="http://schemas.openxmlformats.org/drawingml/2006/main" xmlns:r="http://schemas.openxmlformats.org/officeDocument/2006/relationships" xmlns:p="http://schemas.openxmlformats.org/presentationml/2006/main">
-  <p:cSld>
-    <p:spTree>
-      <p:nvGrpSpPr>
-        <p:cNvPr id="1" name="">
-          <a:extLst>
-            <a:ext uri="{FF2B5EF4-FFF2-40B4-BE49-F238E27FC236}">
-              <a16:creationId xmlns:a16="http://schemas.microsoft.com/office/drawing/2014/main" id="{80D62E45-34F0-5E8D-A38B-24A20381A332}"/>
-            </a:ext>
-          </a:extLst>
-        </p:cNvPr>
-        <p:cNvGrpSpPr/>
-        <p:nvPr/>
-      </p:nvGrpSpPr>
-      <p:grpSpPr>
-        <a:xfrm>
-          <a:off x="0" y="0"/>
-          <a:ext cx="0" cy="0"/>
-          <a:chOff x="0" y="0"/>
-          <a:chExt cx="0" cy="0"/>
-        </a:xfrm>
-      </p:grpSpPr>
-      <p:pic>
-        <p:nvPicPr>
-          <p:cNvPr id="8" name="Imagem 7">
-            <a:extLst>
-              <a:ext uri="{FF2B5EF4-FFF2-40B4-BE49-F238E27FC236}">
-                <a16:creationId xmlns:a16="http://schemas.microsoft.com/office/drawing/2014/main" id="{B8BD386C-81A7-0992-116D-55E1D8A24AF5}"/>
-              </a:ext>
-            </a:extLst>
-          </p:cNvPr>
-          <p:cNvPicPr>
-            <a:picLocks noChangeAspect="1"/>
-          </p:cNvPicPr>
-          <p:nvPr/>
-        </p:nvPicPr>
-        <p:blipFill>
-          <a:blip r:embed="rId2"/>
-          <a:srcRect/>
-          <a:stretch/>
-        </p:blipFill>
-        <p:spPr>
-          <a:xfrm>
-            <a:off x="139700" y="1443566"/>
-            <a:ext cx="11912600" cy="3970867"/>
-          </a:xfrm>
-          <a:prstGeom prst="rect">
-            <a:avLst/>
-          </a:prstGeom>
-        </p:spPr>
-      </p:pic>
-    </p:spTree>
-    <p:extLst>
-      <p:ext uri="{BB962C8B-B14F-4D97-AF65-F5344CB8AC3E}">
-        <p14:creationId xmlns:p14="http://schemas.microsoft.com/office/powerpoint/2010/main" val="3642618796"/>
-      </p:ext>
-    </p:extLst>
-  </p:cSld>
-  <p:clrMapOvr>
-    <a:masterClrMapping/>
-  </p:clrMapOvr>
-</p:sld>
-</file>
-
-<file path=ppt/slides/slide9.xml><?xml version="1.0" encoding="utf-8"?>
-<p:sld xmlns:a="http://schemas.openxmlformats.org/drawingml/2006/main" xmlns:r="http://schemas.openxmlformats.org/officeDocument/2006/relationships" xmlns:p="http://schemas.openxmlformats.org/presentationml/2006/main">
-  <p:cSld>
-    <p:spTree>
-      <p:nvGrpSpPr>
         <p:cNvPr id="1" name="">
           <a:extLst>
             <a:ext uri="{FF2B5EF4-FFF2-40B4-BE49-F238E27FC236}">
@@ -23280,6 +22513,406 @@
     <p:extLst>
       <p:ext uri="{BB962C8B-B14F-4D97-AF65-F5344CB8AC3E}">
         <p14:creationId xmlns:p14="http://schemas.microsoft.com/office/powerpoint/2010/main" val="2139147322"/>
+      </p:ext>
+    </p:extLst>
+  </p:cSld>
+  <p:clrMapOvr>
+    <a:masterClrMapping/>
+  </p:clrMapOvr>
+</p:sld>
+</file>
+
+<file path=ppt/slides/slide6.xml><?xml version="1.0" encoding="utf-8"?>
+<p:sld xmlns:a="http://schemas.openxmlformats.org/drawingml/2006/main" xmlns:r="http://schemas.openxmlformats.org/officeDocument/2006/relationships" xmlns:p="http://schemas.openxmlformats.org/presentationml/2006/main">
+  <p:cSld>
+    <p:spTree>
+      <p:nvGrpSpPr>
+        <p:cNvPr id="1" name="">
+          <a:extLst>
+            <a:ext uri="{FF2B5EF4-FFF2-40B4-BE49-F238E27FC236}">
+              <a16:creationId xmlns:a16="http://schemas.microsoft.com/office/drawing/2014/main" id="{27C4645D-27DF-19C9-6BE3-5B11D1588596}"/>
+            </a:ext>
+          </a:extLst>
+        </p:cNvPr>
+        <p:cNvGrpSpPr/>
+        <p:nvPr/>
+      </p:nvGrpSpPr>
+      <p:grpSpPr>
+        <a:xfrm>
+          <a:off x="0" y="0"/>
+          <a:ext cx="0" cy="0"/>
+          <a:chOff x="0" y="0"/>
+          <a:chExt cx="0" cy="0"/>
+        </a:xfrm>
+      </p:grpSpPr>
+      <p:sp>
+        <p:nvSpPr>
+          <p:cNvPr id="2" name="Título 1">
+            <a:extLst>
+              <a:ext uri="{FF2B5EF4-FFF2-40B4-BE49-F238E27FC236}">
+                <a16:creationId xmlns:a16="http://schemas.microsoft.com/office/drawing/2014/main" id="{5C80BD4D-98BD-97B6-ABAE-960EDAD29F87}"/>
+              </a:ext>
+            </a:extLst>
+          </p:cNvPr>
+          <p:cNvSpPr>
+            <a:spLocks noGrp="1"/>
+          </p:cNvSpPr>
+          <p:nvPr>
+            <p:ph type="title"/>
+          </p:nvPr>
+        </p:nvSpPr>
+        <p:spPr/>
+        <p:txBody>
+          <a:bodyPr/>
+          <a:lstStyle/>
+          <a:p>
+            <a:r>
+              <a:rPr lang="pt-BR" dirty="0"/>
+              <a:t>Conceito</a:t>
+            </a:r>
+          </a:p>
+        </p:txBody>
+      </p:sp>
+      <p:sp>
+        <p:nvSpPr>
+          <p:cNvPr id="3" name="Espaço Reservado para Conteúdo 2">
+            <a:extLst>
+              <a:ext uri="{FF2B5EF4-FFF2-40B4-BE49-F238E27FC236}">
+                <a16:creationId xmlns:a16="http://schemas.microsoft.com/office/drawing/2014/main" id="{3B266C91-195E-4A06-908B-3823A64C5F7E}"/>
+              </a:ext>
+            </a:extLst>
+          </p:cNvPr>
+          <p:cNvSpPr>
+            <a:spLocks noGrp="1"/>
+          </p:cNvSpPr>
+          <p:nvPr>
+            <p:ph idx="1"/>
+          </p:nvPr>
+        </p:nvSpPr>
+        <p:spPr/>
+        <p:txBody>
+          <a:bodyPr>
+            <a:noAutofit/>
+          </a:bodyPr>
+          <a:lstStyle/>
+          <a:p>
+            <a:pPr marL="0" indent="0">
+              <a:buNone/>
+            </a:pPr>
+            <a:r>
+              <a:rPr lang="pt-BR" sz="5000" dirty="0"/>
+              <a:t>Usados na realização de </a:t>
+            </a:r>
+            <a:r>
+              <a:rPr lang="pt-BR" sz="5000" b="1" dirty="0">
+                <a:solidFill>
+                  <a:srgbClr val="7030A0"/>
+                </a:solidFill>
+              </a:rPr>
+              <a:t>cálculos aritméticos simples</a:t>
+            </a:r>
+            <a:r>
+              <a:rPr lang="pt-BR" sz="5000" dirty="0"/>
+              <a:t>, usando as quatro operações básicas da matemática mais operações como o módulo.</a:t>
+            </a:r>
+          </a:p>
+        </p:txBody>
+      </p:sp>
+    </p:spTree>
+    <p:extLst>
+      <p:ext uri="{BB962C8B-B14F-4D97-AF65-F5344CB8AC3E}">
+        <p14:creationId xmlns:p14="http://schemas.microsoft.com/office/powerpoint/2010/main" val="727140148"/>
+      </p:ext>
+    </p:extLst>
+  </p:cSld>
+  <p:clrMapOvr>
+    <a:masterClrMapping/>
+  </p:clrMapOvr>
+</p:sld>
+</file>
+
+<file path=ppt/slides/slide7.xml><?xml version="1.0" encoding="utf-8"?>
+<p:sld xmlns:a="http://schemas.openxmlformats.org/drawingml/2006/main" xmlns:r="http://schemas.openxmlformats.org/officeDocument/2006/relationships" xmlns:p="http://schemas.openxmlformats.org/presentationml/2006/main">
+  <p:cSld>
+    <p:spTree>
+      <p:nvGrpSpPr>
+        <p:cNvPr id="1" name="">
+          <a:extLst>
+            <a:ext uri="{FF2B5EF4-FFF2-40B4-BE49-F238E27FC236}">
+              <a16:creationId xmlns:a16="http://schemas.microsoft.com/office/drawing/2014/main" id="{DC97B1F4-E431-F466-D2C4-901ADB8E143A}"/>
+            </a:ext>
+          </a:extLst>
+        </p:cNvPr>
+        <p:cNvGrpSpPr/>
+        <p:nvPr/>
+      </p:nvGrpSpPr>
+      <p:grpSpPr>
+        <a:xfrm>
+          <a:off x="0" y="0"/>
+          <a:ext cx="0" cy="0"/>
+          <a:chOff x="0" y="0"/>
+          <a:chExt cx="0" cy="0"/>
+        </a:xfrm>
+      </p:grpSpPr>
+      <p:pic>
+        <p:nvPicPr>
+          <p:cNvPr id="9" name="Imagem 8">
+            <a:extLst>
+              <a:ext uri="{FF2B5EF4-FFF2-40B4-BE49-F238E27FC236}">
+                <a16:creationId xmlns:a16="http://schemas.microsoft.com/office/drawing/2014/main" id="{623DDFBA-EF55-3E40-17EF-42E49E6A4A8B}"/>
+              </a:ext>
+            </a:extLst>
+          </p:cNvPr>
+          <p:cNvPicPr>
+            <a:picLocks noChangeAspect="1"/>
+          </p:cNvPicPr>
+          <p:nvPr/>
+        </p:nvPicPr>
+        <p:blipFill>
+          <a:blip r:embed="rId2"/>
+          <a:stretch>
+            <a:fillRect/>
+          </a:stretch>
+        </p:blipFill>
+        <p:spPr>
+          <a:xfrm>
+            <a:off x="257400" y="0"/>
+            <a:ext cx="11677200" cy="6858000"/>
+          </a:xfrm>
+          <a:prstGeom prst="rect">
+            <a:avLst/>
+          </a:prstGeom>
+        </p:spPr>
+      </p:pic>
+    </p:spTree>
+    <p:extLst>
+      <p:ext uri="{BB962C8B-B14F-4D97-AF65-F5344CB8AC3E}">
+        <p14:creationId xmlns:p14="http://schemas.microsoft.com/office/powerpoint/2010/main" val="1350771419"/>
+      </p:ext>
+    </p:extLst>
+  </p:cSld>
+  <p:clrMapOvr>
+    <a:masterClrMapping/>
+  </p:clrMapOvr>
+</p:sld>
+</file>
+
+<file path=ppt/slides/slide8.xml><?xml version="1.0" encoding="utf-8"?>
+<p:sld xmlns:a="http://schemas.openxmlformats.org/drawingml/2006/main" xmlns:r="http://schemas.openxmlformats.org/officeDocument/2006/relationships" xmlns:p="http://schemas.openxmlformats.org/presentationml/2006/main">
+  <p:cSld>
+    <p:spTree>
+      <p:nvGrpSpPr>
+        <p:cNvPr id="1" name="">
+          <a:extLst>
+            <a:ext uri="{FF2B5EF4-FFF2-40B4-BE49-F238E27FC236}">
+              <a16:creationId xmlns:a16="http://schemas.microsoft.com/office/drawing/2014/main" id="{137D7C11-0628-FF0E-4B48-5278DC8D8BEA}"/>
+            </a:ext>
+          </a:extLst>
+        </p:cNvPr>
+        <p:cNvGrpSpPr/>
+        <p:nvPr/>
+      </p:nvGrpSpPr>
+      <p:grpSpPr>
+        <a:xfrm>
+          <a:off x="0" y="0"/>
+          <a:ext cx="0" cy="0"/>
+          <a:chOff x="0" y="0"/>
+          <a:chExt cx="0" cy="0"/>
+        </a:xfrm>
+      </p:grpSpPr>
+      <p:pic>
+        <p:nvPicPr>
+          <p:cNvPr id="9" name="Imagem 8">
+            <a:extLst>
+              <a:ext uri="{FF2B5EF4-FFF2-40B4-BE49-F238E27FC236}">
+                <a16:creationId xmlns:a16="http://schemas.microsoft.com/office/drawing/2014/main" id="{AFD7632F-FB1A-7A2B-9265-C5AA246CB316}"/>
+              </a:ext>
+            </a:extLst>
+          </p:cNvPr>
+          <p:cNvPicPr>
+            <a:picLocks noChangeAspect="1"/>
+          </p:cNvPicPr>
+          <p:nvPr/>
+        </p:nvPicPr>
+        <p:blipFill>
+          <a:blip r:embed="rId2"/>
+          <a:srcRect/>
+          <a:stretch/>
+        </p:blipFill>
+        <p:spPr>
+          <a:xfrm>
+            <a:off x="257400" y="430083"/>
+            <a:ext cx="11677200" cy="5997834"/>
+          </a:xfrm>
+          <a:prstGeom prst="rect">
+            <a:avLst/>
+          </a:prstGeom>
+        </p:spPr>
+      </p:pic>
+    </p:spTree>
+    <p:extLst>
+      <p:ext uri="{BB962C8B-B14F-4D97-AF65-F5344CB8AC3E}">
+        <p14:creationId xmlns:p14="http://schemas.microsoft.com/office/powerpoint/2010/main" val="741721956"/>
+      </p:ext>
+    </p:extLst>
+  </p:cSld>
+  <p:clrMapOvr>
+    <a:masterClrMapping/>
+  </p:clrMapOvr>
+</p:sld>
+</file>
+
+<file path=ppt/slides/slide9.xml><?xml version="1.0" encoding="utf-8"?>
+<p:sld xmlns:a="http://schemas.openxmlformats.org/drawingml/2006/main" xmlns:r="http://schemas.openxmlformats.org/officeDocument/2006/relationships" xmlns:p="http://schemas.openxmlformats.org/presentationml/2006/main">
+  <p:cSld>
+    <p:spTree>
+      <p:nvGrpSpPr>
+        <p:cNvPr id="1" name="">
+          <a:extLst>
+            <a:ext uri="{FF2B5EF4-FFF2-40B4-BE49-F238E27FC236}">
+              <a16:creationId xmlns:a16="http://schemas.microsoft.com/office/drawing/2014/main" id="{0EE355CC-8725-F014-E969-74E1C4F052DD}"/>
+            </a:ext>
+          </a:extLst>
+        </p:cNvPr>
+        <p:cNvGrpSpPr/>
+        <p:nvPr/>
+      </p:nvGrpSpPr>
+      <p:grpSpPr>
+        <a:xfrm>
+          <a:off x="0" y="0"/>
+          <a:ext cx="0" cy="0"/>
+          <a:chOff x="0" y="0"/>
+          <a:chExt cx="0" cy="0"/>
+        </a:xfrm>
+      </p:grpSpPr>
+      <p:sp>
+        <p:nvSpPr>
+          <p:cNvPr id="3" name="Espaço Reservado para Conteúdo 2">
+            <a:extLst>
+              <a:ext uri="{FF2B5EF4-FFF2-40B4-BE49-F238E27FC236}">
+                <a16:creationId xmlns:a16="http://schemas.microsoft.com/office/drawing/2014/main" id="{E5737209-E3FE-700D-1279-75E13CF0CB78}"/>
+              </a:ext>
+            </a:extLst>
+          </p:cNvPr>
+          <p:cNvSpPr>
+            <a:spLocks noGrp="1"/>
+          </p:cNvSpPr>
+          <p:nvPr>
+            <p:ph idx="4294967295"/>
+          </p:nvPr>
+        </p:nvSpPr>
+        <p:spPr>
+          <a:xfrm>
+            <a:off x="1633538" y="652463"/>
+            <a:ext cx="10558462" cy="5656262"/>
+          </a:xfrm>
+        </p:spPr>
+        <p:txBody>
+          <a:bodyPr>
+            <a:noAutofit/>
+          </a:bodyPr>
+          <a:lstStyle/>
+          <a:p>
+            <a:pPr marL="0" indent="0">
+              <a:buNone/>
+            </a:pPr>
+            <a:r>
+              <a:rPr lang="pt-BR" sz="4500" dirty="0">
+                <a:latin typeface="Cascadia Code" panose="020B0609020000020004" pitchFamily="49" charset="0"/>
+                <a:cs typeface="Cascadia Code" panose="020B0609020000020004" pitchFamily="49" charset="0"/>
+              </a:rPr>
+              <a:t>		</a:t>
+            </a:r>
+            <a:r>
+              <a:rPr lang="pl-PL" sz="4500" dirty="0">
+                <a:latin typeface="Cascadia Code" panose="020B0609020000020004" pitchFamily="49" charset="0"/>
+                <a:cs typeface="Cascadia Code" panose="020B0609020000020004" pitchFamily="49" charset="0"/>
+              </a:rPr>
+              <a:t>x = 2 * 3</a:t>
+            </a:r>
+          </a:p>
+          <a:p>
+            <a:pPr marL="0" indent="0">
+              <a:buNone/>
+            </a:pPr>
+            <a:r>
+              <a:rPr lang="pl-PL" sz="4500" dirty="0">
+                <a:latin typeface="Cascadia Code" panose="020B0609020000020004" pitchFamily="49" charset="0"/>
+                <a:cs typeface="Cascadia Code" panose="020B0609020000020004" pitchFamily="49" charset="0"/>
+              </a:rPr>
+              <a:t>		y = 5 * 2 * 2</a:t>
+            </a:r>
+          </a:p>
+          <a:p>
+            <a:pPr marL="0" indent="0">
+              <a:buNone/>
+            </a:pPr>
+            <a:r>
+              <a:rPr lang="pl-PL" sz="4500" dirty="0">
+                <a:latin typeface="Cascadia Code" panose="020B0609020000020004" pitchFamily="49" charset="0"/>
+                <a:cs typeface="Cascadia Code" panose="020B0609020000020004" pitchFamily="49" charset="0"/>
+              </a:rPr>
+              <a:t>		z = 4 % 2</a:t>
+            </a:r>
+          </a:p>
+          <a:p>
+            <a:pPr marL="0" indent="0">
+              <a:buNone/>
+            </a:pPr>
+            <a:r>
+              <a:rPr lang="pl-PL" sz="4500" dirty="0">
+                <a:latin typeface="Cascadia Code" panose="020B0609020000020004" pitchFamily="49" charset="0"/>
+                <a:cs typeface="Cascadia Code" panose="020B0609020000020004" pitchFamily="49" charset="0"/>
+              </a:rPr>
+              <a:t>		w = 8 / 4</a:t>
+            </a:r>
+          </a:p>
+          <a:p>
+            <a:pPr marL="0" indent="0">
+              <a:buNone/>
+            </a:pPr>
+            <a:r>
+              <a:rPr lang="pl-PL" sz="4500" dirty="0">
+                <a:latin typeface="Cascadia Code" panose="020B0609020000020004" pitchFamily="49" charset="0"/>
+                <a:cs typeface="Cascadia Code" panose="020B0609020000020004" pitchFamily="49" charset="0"/>
+              </a:rPr>
+              <a:t>		k = 7 / 2</a:t>
+            </a:r>
+          </a:p>
+          <a:p>
+            <a:pPr marL="0" indent="0">
+              <a:buNone/>
+            </a:pPr>
+            <a:r>
+              <a:rPr lang="pl-PL" sz="4500" dirty="0">
+                <a:latin typeface="Cascadia Code" panose="020B0609020000020004" pitchFamily="49" charset="0"/>
+                <a:cs typeface="Cascadia Code" panose="020B0609020000020004" pitchFamily="49" charset="0"/>
+              </a:rPr>
+              <a:t>		m = w + x * 3</a:t>
+            </a:r>
+          </a:p>
+          <a:p>
+            <a:pPr marL="0" indent="0">
+              <a:buNone/>
+            </a:pPr>
+            <a:r>
+              <a:rPr lang="pl-PL" sz="4500" dirty="0">
+                <a:latin typeface="Cascadia Code" panose="020B0609020000020004" pitchFamily="49" charset="0"/>
+                <a:cs typeface="Cascadia Code" panose="020B0609020000020004" pitchFamily="49" charset="0"/>
+              </a:rPr>
+              <a:t>		n = (m - k) / 2.0</a:t>
+            </a:r>
+            <a:endParaRPr lang="pt-BR" sz="4500" dirty="0">
+              <a:latin typeface="Cascadia Code" panose="020B0609020000020004" pitchFamily="49" charset="0"/>
+              <a:cs typeface="Cascadia Code" panose="020B0609020000020004" pitchFamily="49" charset="0"/>
+            </a:endParaRPr>
+          </a:p>
+        </p:txBody>
+      </p:sp>
+    </p:spTree>
+    <p:extLst>
+      <p:ext uri="{BB962C8B-B14F-4D97-AF65-F5344CB8AC3E}">
+        <p14:creationId xmlns:p14="http://schemas.microsoft.com/office/powerpoint/2010/main" val="1121112338"/>
       </p:ext>
     </p:extLst>
   </p:cSld>
@@ -24114,15 +23747,6 @@
 </file>
 
 <file path=customXml/item1.xml><?xml version="1.0" encoding="utf-8"?>
-<?mso-contentType ?>
-<FormTemplates xmlns="http://schemas.microsoft.com/sharepoint/v3/contenttype/forms">
-  <Display>DocumentLibraryForm</Display>
-  <Edit>DocumentLibraryForm</Edit>
-  <New>DocumentLibraryForm</New>
-</FormTemplates>
-</file>
-
-<file path=customXml/item2.xml><?xml version="1.0" encoding="utf-8"?>
 <ct:contentTypeSchema xmlns:ct="http://schemas.microsoft.com/office/2006/metadata/contentType" xmlns:ma="http://schemas.microsoft.com/office/2006/metadata/properties/metaAttributes" ct:_="" ma:_="" ma:contentTypeName="Document" ma:contentTypeID="0x01010079F111ED35F8CC479449609E8A0923A6" ma:contentTypeVersion="11" ma:contentTypeDescription="Create a new document." ma:contentTypeScope="" ma:versionID="9677210f24a1be23c92c90fd886aa0aa">
   <xsd:schema xmlns:xsd="http://www.w3.org/2001/XMLSchema" xmlns:xs="http://www.w3.org/2001/XMLSchema" xmlns:p="http://schemas.microsoft.com/office/2006/metadata/properties" xmlns:ns2="71af3243-3dd4-4a8d-8c0d-dd76da1f02a5" xmlns:ns3="16c05727-aa75-4e4a-9b5f-8a80a1165891" targetNamespace="http://schemas.microsoft.com/office/2006/metadata/properties" ma:root="true" ma:fieldsID="60e05723c5c1908df1a1a4ebf11d344e" ns2:_="" ns3:_="">
     <xsd:import namespace="71af3243-3dd4-4a8d-8c0d-dd76da1f02a5"/>
@@ -24333,6 +23957,15 @@
 </ct:contentTypeSchema>
 </file>
 
+<file path=customXml/item2.xml><?xml version="1.0" encoding="utf-8"?>
+<?mso-contentType ?>
+<FormTemplates xmlns="http://schemas.microsoft.com/sharepoint/v3/contenttype/forms">
+  <Display>DocumentLibraryForm</Display>
+  <Edit>DocumentLibraryForm</Edit>
+  <New>DocumentLibraryForm</New>
+</FormTemplates>
+</file>
+
 <file path=customXml/item3.xml><?xml version="1.0" encoding="utf-8"?>
 <p:properties xmlns:p="http://schemas.microsoft.com/office/2006/metadata/properties" xmlns:xsi="http://www.w3.org/2001/XMLSchema-instance" xmlns:pc="http://schemas.microsoft.com/office/infopath/2007/PartnerControls">
   <documentManagement>
@@ -24342,14 +23975,6 @@
 </file>
 
 <file path=customXml/itemProps1.xml><?xml version="1.0" encoding="utf-8"?>
-<ds:datastoreItem xmlns:ds="http://schemas.openxmlformats.org/officeDocument/2006/customXml" ds:itemID="{4F44C90D-2A62-4985-9618-3460247437B1}">
-  <ds:schemaRefs>
-    <ds:schemaRef ds:uri="http://schemas.microsoft.com/sharepoint/v3/contenttype/forms"/>
-  </ds:schemaRefs>
-</ds:datastoreItem>
-</file>
-
-<file path=customXml/itemProps2.xml><?xml version="1.0" encoding="utf-8"?>
 <ds:datastoreItem xmlns:ds="http://schemas.openxmlformats.org/officeDocument/2006/customXml" ds:itemID="{B61EAB5F-88FC-4FAE-AE3C-037A3C365EB8}">
   <ds:schemaRefs>
     <ds:schemaRef ds:uri="http://schemas.microsoft.com/office/2006/metadata/contentType"/>
@@ -24364,6 +23989,14 @@
     <ds:schemaRef ds:uri="http://purl.org/dc/elements/1.1/"/>
     <ds:schemaRef ds:uri="http://purl.org/dc/terms/"/>
     <ds:schemaRef ds:uri="http://schemas.microsoft.com/internal/obd"/>
+  </ds:schemaRefs>
+</ds:datastoreItem>
+</file>
+
+<file path=customXml/itemProps2.xml><?xml version="1.0" encoding="utf-8"?>
+<ds:datastoreItem xmlns:ds="http://schemas.openxmlformats.org/officeDocument/2006/customXml" ds:itemID="{4F44C90D-2A62-4985-9618-3460247437B1}">
+  <ds:schemaRefs>
+    <ds:schemaRef ds:uri="http://schemas.microsoft.com/sharepoint/v3/contenttype/forms"/>
   </ds:schemaRefs>
 </ds:datastoreItem>
 </file>

</xml_diff>